<commit_message>
Update PowerPoint for song #225 in FUBC - Українські
</commit_message>
<xml_diff>
--- a/fubc-ua/225-Чую заклик я Ісуса (Пісні Спасенних №224).pptx
+++ b/fubc-ua/225-Чую заклик я Ісуса (Пісні Спасенних №224).pptx
@@ -1676,7 +1676,7 @@
         </p:nvSpPr>
         <p:spPr>
           <a:xfrm>
-            <a:off x="2576474" y="2359152"/>
+            <a:off x="2675534" y="2359152"/>
             <a:ext cx="0" cy="594360"/>
           </a:xfrm>
           <a:prstGeom prst="line">
@@ -1699,7 +1699,7 @@
         </p:nvSpPr>
         <p:spPr>
           <a:xfrm>
-            <a:off x="9621622" y="2359152"/>
+            <a:off x="9522562" y="2359152"/>
             <a:ext cx="0" cy="594360"/>
           </a:xfrm>
           <a:prstGeom prst="line">
@@ -1722,8 +1722,8 @@
         </p:nvSpPr>
         <p:spPr>
           <a:xfrm>
-            <a:off x="9753702" y="2425192"/>
-            <a:ext cx="792480" cy="462280"/>
+            <a:off x="9621622" y="2336292"/>
+            <a:ext cx="1097280" cy="640080"/>
           </a:xfrm>
           <a:prstGeom prst="rect">
             <a:avLst/>
@@ -1739,9 +1739,9 @@
               <a:buNone/>
             </a:pPr>
             <a:r>
-              <a:rPr lang="en-US" sz="2600" b="1" dirty="0">
+              <a:rPr lang="en-US" sz="3600" b="1" dirty="0">
                 <a:solidFill>
-                  <a:srgbClr val="8A8A8A"/>
+                  <a:srgbClr val="BBBBBB"/>
                 </a:solidFill>
                 <a:latin typeface="Arial" pitchFamily="34" charset="0"/>
                 <a:ea typeface="Arial" pitchFamily="34" charset="-122"/>
@@ -1749,7 +1749,7 @@
               </a:rPr>
               <a:t>×3</a:t>
             </a:r>
-            <a:endParaRPr lang="en-US" sz="2600" dirty="0"/>
+            <a:endParaRPr lang="en-US" sz="3600" dirty="0"/>
           </a:p>
         </p:txBody>
       </p:sp>
@@ -1855,7 +1855,7 @@
         </p:nvSpPr>
         <p:spPr>
           <a:xfrm>
-            <a:off x="1758239" y="2755392"/>
+            <a:off x="1857299" y="2755392"/>
             <a:ext cx="0" cy="594360"/>
           </a:xfrm>
           <a:prstGeom prst="line">
@@ -1878,7 +1878,7 @@
         </p:nvSpPr>
         <p:spPr>
           <a:xfrm>
-            <a:off x="10439857" y="2755392"/>
+            <a:off x="10340797" y="2755392"/>
             <a:ext cx="0" cy="594360"/>
           </a:xfrm>
           <a:prstGeom prst="line">
@@ -1901,8 +1901,8 @@
         </p:nvSpPr>
         <p:spPr>
           <a:xfrm>
-            <a:off x="10571937" y="2821432"/>
-            <a:ext cx="792480" cy="462280"/>
+            <a:off x="10439857" y="2732532"/>
+            <a:ext cx="1097280" cy="640080"/>
           </a:xfrm>
           <a:prstGeom prst="rect">
             <a:avLst/>
@@ -1918,9 +1918,9 @@
               <a:buNone/>
             </a:pPr>
             <a:r>
-              <a:rPr lang="en-US" sz="2600" b="1" dirty="0">
+              <a:rPr lang="en-US" sz="3600" b="1" dirty="0">
                 <a:solidFill>
-                  <a:srgbClr val="8A8A8A"/>
+                  <a:srgbClr val="BBBBBB"/>
                 </a:solidFill>
                 <a:latin typeface="Arial" pitchFamily="34" charset="0"/>
                 <a:ea typeface="Arial" pitchFamily="34" charset="-122"/>
@@ -1928,7 +1928,7 @@
               </a:rPr>
               <a:t>×3</a:t>
             </a:r>
-            <a:endParaRPr lang="en-US" sz="2600" dirty="0"/>
+            <a:endParaRPr lang="en-US" sz="3600" dirty="0"/>
           </a:p>
         </p:txBody>
       </p:sp>
@@ -2034,7 +2034,7 @@
         </p:nvSpPr>
         <p:spPr>
           <a:xfrm>
-            <a:off x="1169822" y="2755392"/>
+            <a:off x="1268882" y="2755392"/>
             <a:ext cx="0" cy="594360"/>
           </a:xfrm>
           <a:prstGeom prst="line">
@@ -2057,7 +2057,7 @@
         </p:nvSpPr>
         <p:spPr>
           <a:xfrm>
-            <a:off x="11028274" y="2755392"/>
+            <a:off x="10929214" y="2755392"/>
             <a:ext cx="0" cy="594360"/>
           </a:xfrm>
           <a:prstGeom prst="line">
@@ -2080,8 +2080,8 @@
         </p:nvSpPr>
         <p:spPr>
           <a:xfrm>
-            <a:off x="11160354" y="2821432"/>
-            <a:ext cx="792480" cy="462280"/>
+            <a:off x="11028274" y="2732532"/>
+            <a:ext cx="1097280" cy="640080"/>
           </a:xfrm>
           <a:prstGeom prst="rect">
             <a:avLst/>
@@ -2097,9 +2097,9 @@
               <a:buNone/>
             </a:pPr>
             <a:r>
-              <a:rPr lang="en-US" sz="2600" b="1" dirty="0">
+              <a:rPr lang="en-US" sz="3600" b="1" dirty="0">
                 <a:solidFill>
-                  <a:srgbClr val="8A8A8A"/>
+                  <a:srgbClr val="BBBBBB"/>
                 </a:solidFill>
                 <a:latin typeface="Arial" pitchFamily="34" charset="0"/>
                 <a:ea typeface="Arial" pitchFamily="34" charset="-122"/>
@@ -2107,7 +2107,7 @@
               </a:rPr>
               <a:t>×3</a:t>
             </a:r>
-            <a:endParaRPr lang="en-US" sz="2600" dirty="0"/>
+            <a:endParaRPr lang="en-US" sz="3600" dirty="0"/>
           </a:p>
         </p:txBody>
       </p:sp>
@@ -2213,7 +2213,7 @@
         </p:nvSpPr>
         <p:spPr>
           <a:xfrm>
-            <a:off x="1527099" y="2755392"/>
+            <a:off x="1626159" y="2755392"/>
             <a:ext cx="0" cy="594360"/>
           </a:xfrm>
           <a:prstGeom prst="line">
@@ -2236,7 +2236,7 @@
         </p:nvSpPr>
         <p:spPr>
           <a:xfrm>
-            <a:off x="10670997" y="2755392"/>
+            <a:off x="10571937" y="2755392"/>
             <a:ext cx="0" cy="594360"/>
           </a:xfrm>
           <a:prstGeom prst="line">
@@ -2259,8 +2259,8 @@
         </p:nvSpPr>
         <p:spPr>
           <a:xfrm>
-            <a:off x="10803077" y="2821432"/>
-            <a:ext cx="792480" cy="462280"/>
+            <a:off x="10670997" y="2732532"/>
+            <a:ext cx="1097280" cy="640080"/>
           </a:xfrm>
           <a:prstGeom prst="rect">
             <a:avLst/>
@@ -2276,9 +2276,9 @@
               <a:buNone/>
             </a:pPr>
             <a:r>
-              <a:rPr lang="en-US" sz="2600" b="1" dirty="0">
+              <a:rPr lang="en-US" sz="3600" b="1" dirty="0">
                 <a:solidFill>
-                  <a:srgbClr val="8A8A8A"/>
+                  <a:srgbClr val="BBBBBB"/>
                 </a:solidFill>
                 <a:latin typeface="Arial" pitchFamily="34" charset="0"/>
                 <a:ea typeface="Arial" pitchFamily="34" charset="-122"/>
@@ -2286,7 +2286,7 @@
               </a:rPr>
               <a:t>×3</a:t>
             </a:r>
-            <a:endParaRPr lang="en-US" sz="2600" dirty="0"/>
+            <a:endParaRPr lang="en-US" sz="3600" dirty="0"/>
           </a:p>
         </p:txBody>
       </p:sp>
@@ -2392,7 +2392,7 @@
         </p:nvSpPr>
         <p:spPr>
           <a:xfrm>
-            <a:off x="1173785" y="2755392"/>
+            <a:off x="1272845" y="2755392"/>
             <a:ext cx="0" cy="594360"/>
           </a:xfrm>
           <a:prstGeom prst="line">
@@ -2415,7 +2415,7 @@
         </p:nvSpPr>
         <p:spPr>
           <a:xfrm>
-            <a:off x="11024311" y="2755392"/>
+            <a:off x="10925251" y="2755392"/>
             <a:ext cx="0" cy="594360"/>
           </a:xfrm>
           <a:prstGeom prst="line">
@@ -2438,8 +2438,8 @@
         </p:nvSpPr>
         <p:spPr>
           <a:xfrm>
-            <a:off x="11156391" y="2821432"/>
-            <a:ext cx="792480" cy="462280"/>
+            <a:off x="11024311" y="2732532"/>
+            <a:ext cx="1097280" cy="640080"/>
           </a:xfrm>
           <a:prstGeom prst="rect">
             <a:avLst/>
@@ -2455,9 +2455,9 @@
               <a:buNone/>
             </a:pPr>
             <a:r>
-              <a:rPr lang="en-US" sz="2600" b="1" dirty="0">
+              <a:rPr lang="en-US" sz="3600" b="1" dirty="0">
                 <a:solidFill>
-                  <a:srgbClr val="8A8A8A"/>
+                  <a:srgbClr val="BBBBBB"/>
                 </a:solidFill>
                 <a:latin typeface="Arial" pitchFamily="34" charset="0"/>
                 <a:ea typeface="Arial" pitchFamily="34" charset="-122"/>
@@ -2465,7 +2465,7 @@
               </a:rPr>
               <a:t>×3</a:t>
             </a:r>
-            <a:endParaRPr lang="en-US" sz="2600" dirty="0"/>
+            <a:endParaRPr lang="en-US" sz="3600" dirty="0"/>
           </a:p>
         </p:txBody>
       </p:sp>
@@ -2571,7 +2571,7 @@
         </p:nvSpPr>
         <p:spPr>
           <a:xfrm>
-            <a:off x="2307031" y="2755392"/>
+            <a:off x="2406091" y="2755392"/>
             <a:ext cx="0" cy="594360"/>
           </a:xfrm>
           <a:prstGeom prst="line">
@@ -2594,7 +2594,7 @@
         </p:nvSpPr>
         <p:spPr>
           <a:xfrm>
-            <a:off x="9891065" y="2755392"/>
+            <a:off x="9792005" y="2755392"/>
             <a:ext cx="0" cy="594360"/>
           </a:xfrm>
           <a:prstGeom prst="line">
@@ -2617,8 +2617,8 @@
         </p:nvSpPr>
         <p:spPr>
           <a:xfrm>
-            <a:off x="10023145" y="2821432"/>
-            <a:ext cx="792480" cy="462280"/>
+            <a:off x="9891065" y="2732532"/>
+            <a:ext cx="1097280" cy="640080"/>
           </a:xfrm>
           <a:prstGeom prst="rect">
             <a:avLst/>
@@ -2634,9 +2634,9 @@
               <a:buNone/>
             </a:pPr>
             <a:r>
-              <a:rPr lang="en-US" sz="2600" b="1" dirty="0">
+              <a:rPr lang="en-US" sz="3600" b="1" dirty="0">
                 <a:solidFill>
-                  <a:srgbClr val="8A8A8A"/>
+                  <a:srgbClr val="BBBBBB"/>
                 </a:solidFill>
                 <a:latin typeface="Arial" pitchFamily="34" charset="0"/>
                 <a:ea typeface="Arial" pitchFamily="34" charset="-122"/>
@@ -2644,7 +2644,7 @@
               </a:rPr>
               <a:t>×3</a:t>
             </a:r>
-            <a:endParaRPr lang="en-US" sz="2600" dirty="0"/>
+            <a:endParaRPr lang="en-US" sz="3600" dirty="0"/>
           </a:p>
         </p:txBody>
       </p:sp>

</xml_diff>